<commit_message>
[slides] modified Lecture 11
</commit_message>
<xml_diff>
--- a/CMQMS_Lecture_11.pptx
+++ b/CMQMS_Lecture_11.pptx
@@ -6,11 +6,12 @@
     <p:sldMasterId id="2147483675" r:id="rId2"/>
   </p:sldMasterIdLst>
   <p:notesMasterIdLst>
-    <p:notesMasterId r:id="rId5"/>
+    <p:notesMasterId r:id="rId6"/>
   </p:notesMasterIdLst>
   <p:sldIdLst>
     <p:sldId id="256" r:id="rId3"/>
     <p:sldId id="623" r:id="rId4"/>
+    <p:sldId id="624" r:id="rId5"/>
   </p:sldIdLst>
   <p:sldSz cx="9144000" cy="6858000" type="screen4x3"/>
   <p:notesSz cx="6858000" cy="9144000"/>
@@ -211,7 +212,7 @@
             <a:fld id="{C8BCEECD-F39C-4D02-890D-AC0AE91B6A27}" type="datetimeFigureOut">
               <a:rPr lang="en-US" smtClean="0"/>
               <a:pPr/>
-              <a:t>10/21/25</a:t>
+              <a:t>10/27/25</a:t>
             </a:fld>
             <a:endParaRPr lang="en-US"/>
           </a:p>
@@ -638,6 +639,91 @@
     <p:extLst>
       <p:ext uri="{BB962C8B-B14F-4D97-AF65-F5344CB8AC3E}">
         <p14:creationId xmlns:p14="http://schemas.microsoft.com/office/powerpoint/2010/main" val="983069369"/>
+      </p:ext>
+    </p:extLst>
+  </p:cSld>
+  <p:clrMapOvr>
+    <a:masterClrMapping/>
+  </p:clrMapOvr>
+</p:notes>
+</file>
+
+<file path=ppt/notesSlides/notesSlide3.xml><?xml version="1.0" encoding="utf-8"?>
+<p:notes xmlns:a="http://schemas.openxmlformats.org/drawingml/2006/main" xmlns:r="http://schemas.openxmlformats.org/officeDocument/2006/relationships" xmlns:p="http://schemas.openxmlformats.org/presentationml/2006/main">
+  <p:cSld>
+    <p:spTree>
+      <p:nvGrpSpPr>
+        <p:cNvPr id="1" name=""/>
+        <p:cNvGrpSpPr/>
+        <p:nvPr/>
+      </p:nvGrpSpPr>
+      <p:grpSpPr>
+        <a:xfrm>
+          <a:off x="0" y="0"/>
+          <a:ext cx="0" cy="0"/>
+          <a:chOff x="0" y="0"/>
+          <a:chExt cx="0" cy="0"/>
+        </a:xfrm>
+      </p:grpSpPr>
+      <p:sp>
+        <p:nvSpPr>
+          <p:cNvPr id="2" name="Slide Image Placeholder 1"/>
+          <p:cNvSpPr>
+            <a:spLocks noGrp="1" noRot="1" noChangeAspect="1"/>
+          </p:cNvSpPr>
+          <p:nvPr>
+            <p:ph type="sldImg"/>
+          </p:nvPr>
+        </p:nvSpPr>
+        <p:spPr/>
+      </p:sp>
+      <p:sp>
+        <p:nvSpPr>
+          <p:cNvPr id="3" name="Notes Placeholder 2"/>
+          <p:cNvSpPr>
+            <a:spLocks noGrp="1"/>
+          </p:cNvSpPr>
+          <p:nvPr>
+            <p:ph type="body" idx="1"/>
+          </p:nvPr>
+        </p:nvSpPr>
+        <p:spPr/>
+        <p:txBody>
+          <a:bodyPr/>
+          <a:lstStyle/>
+          <a:p>
+            <a:endParaRPr lang="en-US" dirty="0"/>
+          </a:p>
+        </p:txBody>
+      </p:sp>
+      <p:sp>
+        <p:nvSpPr>
+          <p:cNvPr id="4" name="Slide Number Placeholder 3"/>
+          <p:cNvSpPr>
+            <a:spLocks noGrp="1"/>
+          </p:cNvSpPr>
+          <p:nvPr>
+            <p:ph type="sldNum" sz="quarter" idx="5"/>
+          </p:nvPr>
+        </p:nvSpPr>
+        <p:spPr/>
+        <p:txBody>
+          <a:bodyPr/>
+          <a:lstStyle/>
+          <a:p>
+            <a:fld id="{04D8C5A7-0305-4EBC-87F9-6BE751D08921}" type="slidenum">
+              <a:rPr lang="en-US" smtClean="0"/>
+              <a:pPr/>
+              <a:t>3</a:t>
+            </a:fld>
+            <a:endParaRPr lang="en-US"/>
+          </a:p>
+        </p:txBody>
+      </p:sp>
+    </p:spTree>
+    <p:extLst>
+      <p:ext uri="{BB962C8B-B14F-4D97-AF65-F5344CB8AC3E}">
+        <p14:creationId xmlns:p14="http://schemas.microsoft.com/office/powerpoint/2010/main" val="500310422"/>
       </p:ext>
     </p:extLst>
   </p:cSld>
@@ -7597,6 +7683,208 @@
             <a:pPr algn="l"/>
             <a:r>
               <a:rPr lang="en-GB" sz="2400" b="1" dirty="0"/>
+              <a:t>Quantum dots: Nobel prize 2023 and application potential</a:t>
+            </a:r>
+            <a:endParaRPr lang="en-GB" sz="2400" b="1" dirty="0">
+              <a:solidFill>
+                <a:srgbClr val="FF0000"/>
+              </a:solidFill>
+            </a:endParaRPr>
+          </a:p>
+        </p:txBody>
+      </p:sp>
+      <p:pic>
+        <p:nvPicPr>
+          <p:cNvPr id="12" name="Picture 11">
+            <a:extLst>
+              <a:ext uri="{FF2B5EF4-FFF2-40B4-BE49-F238E27FC236}">
+                <a16:creationId xmlns:a16="http://schemas.microsoft.com/office/drawing/2014/main" id="{CF61BBBF-64F3-C441-26B9-A1750C7812BF}"/>
+              </a:ext>
+            </a:extLst>
+          </p:cNvPr>
+          <p:cNvPicPr>
+            <a:picLocks noChangeAspect="1"/>
+          </p:cNvPicPr>
+          <p:nvPr/>
+        </p:nvPicPr>
+        <p:blipFill>
+          <a:blip r:embed="rId3"/>
+          <a:stretch>
+            <a:fillRect/>
+          </a:stretch>
+        </p:blipFill>
+        <p:spPr>
+          <a:xfrm>
+            <a:off x="323528" y="2061509"/>
+            <a:ext cx="3152486" cy="3152486"/>
+          </a:xfrm>
+          <a:prstGeom prst="rect">
+            <a:avLst/>
+          </a:prstGeom>
+        </p:spPr>
+      </p:pic>
+      <p:pic>
+        <p:nvPicPr>
+          <p:cNvPr id="1026" name="Picture 2" descr="Schematic picture of a quantum dot (QD) display. | Download Scientific  Diagram">
+            <a:extLst>
+              <a:ext uri="{FF2B5EF4-FFF2-40B4-BE49-F238E27FC236}">
+                <a16:creationId xmlns:a16="http://schemas.microsoft.com/office/drawing/2014/main" id="{4C3792E3-A232-CE92-1D26-083614B26B18}"/>
+              </a:ext>
+            </a:extLst>
+          </p:cNvPr>
+          <p:cNvPicPr>
+            <a:picLocks noChangeAspect="1" noChangeArrowheads="1"/>
+          </p:cNvPicPr>
+          <p:nvPr/>
+        </p:nvPicPr>
+        <p:blipFill>
+          <a:blip r:embed="rId4">
+            <a:extLst>
+              <a:ext uri="{28A0092B-C50C-407E-A947-70E740481C1C}">
+                <a14:useLocalDpi xmlns:a14="http://schemas.microsoft.com/office/drawing/2010/main" val="0"/>
+              </a:ext>
+            </a:extLst>
+          </a:blip>
+          <a:srcRect/>
+          <a:stretch>
+            <a:fillRect/>
+          </a:stretch>
+        </p:blipFill>
+        <p:spPr bwMode="auto">
+          <a:xfrm>
+            <a:off x="3734118" y="1448977"/>
+            <a:ext cx="3429000" cy="2374900"/>
+          </a:xfrm>
+          <a:prstGeom prst="rect">
+            <a:avLst/>
+          </a:prstGeom>
+          <a:noFill/>
+          <a:extLst>
+            <a:ext uri="{909E8E84-426E-40DD-AFC4-6F175D3DCCD1}">
+              <a14:hiddenFill xmlns:a14="http://schemas.microsoft.com/office/drawing/2010/main">
+                <a:solidFill>
+                  <a:srgbClr val="FFFFFF"/>
+                </a:solidFill>
+              </a14:hiddenFill>
+            </a:ext>
+          </a:extLst>
+        </p:spPr>
+      </p:pic>
+      <p:pic>
+        <p:nvPicPr>
+          <p:cNvPr id="13" name="Picture 12">
+            <a:extLst>
+              <a:ext uri="{FF2B5EF4-FFF2-40B4-BE49-F238E27FC236}">
+                <a16:creationId xmlns:a16="http://schemas.microsoft.com/office/drawing/2014/main" id="{A8A47548-9B82-2590-B3F0-A807411427A0}"/>
+              </a:ext>
+            </a:extLst>
+          </p:cNvPr>
+          <p:cNvPicPr>
+            <a:picLocks noChangeAspect="1"/>
+          </p:cNvPicPr>
+          <p:nvPr/>
+        </p:nvPicPr>
+        <p:blipFill>
+          <a:blip r:embed="rId5"/>
+          <a:stretch>
+            <a:fillRect/>
+          </a:stretch>
+        </p:blipFill>
+        <p:spPr>
+          <a:xfrm>
+            <a:off x="3734118" y="4379976"/>
+            <a:ext cx="3708400" cy="2085975"/>
+          </a:xfrm>
+          <a:prstGeom prst="rect">
+            <a:avLst/>
+          </a:prstGeom>
+        </p:spPr>
+      </p:pic>
+      <p:pic>
+        <p:nvPicPr>
+          <p:cNvPr id="14" name="Picture 13">
+            <a:extLst>
+              <a:ext uri="{FF2B5EF4-FFF2-40B4-BE49-F238E27FC236}">
+                <a16:creationId xmlns:a16="http://schemas.microsoft.com/office/drawing/2014/main" id="{3DFB14DA-0DF4-B1A2-F319-8533F8D89F1F}"/>
+              </a:ext>
+            </a:extLst>
+          </p:cNvPr>
+          <p:cNvPicPr>
+            <a:picLocks noChangeAspect="1"/>
+          </p:cNvPicPr>
+          <p:nvPr/>
+        </p:nvPicPr>
+        <p:blipFill>
+          <a:blip r:embed="rId6"/>
+          <a:stretch>
+            <a:fillRect/>
+          </a:stretch>
+        </p:blipFill>
+        <p:spPr>
+          <a:xfrm>
+            <a:off x="6649255" y="2547527"/>
+            <a:ext cx="2501900" cy="2552700"/>
+          </a:xfrm>
+          <a:prstGeom prst="rect">
+            <a:avLst/>
+          </a:prstGeom>
+        </p:spPr>
+      </p:pic>
+    </p:spTree>
+    <p:extLst>
+      <p:ext uri="{BB962C8B-B14F-4D97-AF65-F5344CB8AC3E}">
+        <p14:creationId xmlns:p14="http://schemas.microsoft.com/office/powerpoint/2010/main" val="3410110083"/>
+      </p:ext>
+    </p:extLst>
+  </p:cSld>
+  <p:clrMapOvr>
+    <a:masterClrMapping/>
+  </p:clrMapOvr>
+</p:sld>
+</file>
+
+<file path=ppt/slides/slide3.xml><?xml version="1.0" encoding="utf-8"?>
+<p:sld xmlns:a="http://schemas.openxmlformats.org/drawingml/2006/main" xmlns:r="http://schemas.openxmlformats.org/officeDocument/2006/relationships" xmlns:p="http://schemas.openxmlformats.org/presentationml/2006/main">
+  <p:cSld>
+    <p:spTree>
+      <p:nvGrpSpPr>
+        <p:cNvPr id="1" name=""/>
+        <p:cNvGrpSpPr/>
+        <p:nvPr/>
+      </p:nvGrpSpPr>
+      <p:grpSpPr>
+        <a:xfrm>
+          <a:off x="0" y="0"/>
+          <a:ext cx="0" cy="0"/>
+          <a:chOff x="0" y="0"/>
+          <a:chExt cx="0" cy="0"/>
+        </a:xfrm>
+      </p:grpSpPr>
+      <p:sp>
+        <p:nvSpPr>
+          <p:cNvPr id="22" name="Title 3"/>
+          <p:cNvSpPr>
+            <a:spLocks noGrp="1"/>
+          </p:cNvSpPr>
+          <p:nvPr>
+            <p:ph type="title"/>
+          </p:nvPr>
+        </p:nvSpPr>
+        <p:spPr>
+          <a:xfrm>
+            <a:off x="0" y="16778"/>
+            <a:ext cx="9144000" cy="1069514"/>
+          </a:xfrm>
+        </p:spPr>
+        <p:txBody>
+          <a:bodyPr>
+            <a:normAutofit/>
+          </a:bodyPr>
+          <a:lstStyle/>
+          <a:p>
+            <a:pPr algn="l"/>
+            <a:r>
+              <a:rPr lang="en-GB" sz="2400" b="1" dirty="0"/>
               <a:t>Quantum dots: density of states, samples and </a:t>
             </a:r>
             <a:br>
@@ -8052,13 +8340,247 @@
     </p:spTree>
     <p:extLst>
       <p:ext uri="{BB962C8B-B14F-4D97-AF65-F5344CB8AC3E}">
-        <p14:creationId xmlns:p14="http://schemas.microsoft.com/office/powerpoint/2010/main" val="3410110083"/>
+        <p14:creationId xmlns:p14="http://schemas.microsoft.com/office/powerpoint/2010/main" val="2307567490"/>
       </p:ext>
     </p:extLst>
   </p:cSld>
   <p:clrMapOvr>
     <a:masterClrMapping/>
   </p:clrMapOvr>
+  <p:timing>
+    <p:tnLst>
+      <p:par>
+        <p:cTn id="1" dur="indefinite" restart="never" nodeType="tmRoot">
+          <p:childTnLst>
+            <p:seq concurrent="1" nextAc="seek">
+              <p:cTn id="2" dur="indefinite" nodeType="mainSeq">
+                <p:childTnLst>
+                  <p:par>
+                    <p:cTn id="3" fill="hold">
+                      <p:stCondLst>
+                        <p:cond delay="indefinite"/>
+                      </p:stCondLst>
+                      <p:childTnLst>
+                        <p:par>
+                          <p:cTn id="4" fill="hold">
+                            <p:stCondLst>
+                              <p:cond delay="0"/>
+                            </p:stCondLst>
+                            <p:childTnLst>
+                              <p:par>
+                                <p:cTn id="5" presetID="1" presetClass="entr" presetSubtype="0" fill="hold" nodeType="clickEffect">
+                                  <p:stCondLst>
+                                    <p:cond delay="0"/>
+                                  </p:stCondLst>
+                                  <p:childTnLst>
+                                    <p:set>
+                                      <p:cBhvr>
+                                        <p:cTn id="6" dur="1" fill="hold">
+                                          <p:stCondLst>
+                                            <p:cond delay="0"/>
+                                          </p:stCondLst>
+                                        </p:cTn>
+                                        <p:tgtEl>
+                                          <p:spTgt spid="4"/>
+                                        </p:tgtEl>
+                                        <p:attrNameLst>
+                                          <p:attrName>style.visibility</p:attrName>
+                                        </p:attrNameLst>
+                                      </p:cBhvr>
+                                      <p:to>
+                                        <p:strVal val="visible"/>
+                                      </p:to>
+                                    </p:set>
+                                  </p:childTnLst>
+                                </p:cTn>
+                              </p:par>
+                              <p:par>
+                                <p:cTn id="7" presetID="1" presetClass="entr" presetSubtype="0" fill="hold" grpId="0" nodeType="withEffect">
+                                  <p:stCondLst>
+                                    <p:cond delay="0"/>
+                                  </p:stCondLst>
+                                  <p:childTnLst>
+                                    <p:set>
+                                      <p:cBhvr>
+                                        <p:cTn id="8" dur="1" fill="hold">
+                                          <p:stCondLst>
+                                            <p:cond delay="0"/>
+                                          </p:stCondLst>
+                                        </p:cTn>
+                                        <p:tgtEl>
+                                          <p:spTgt spid="7"/>
+                                        </p:tgtEl>
+                                        <p:attrNameLst>
+                                          <p:attrName>style.visibility</p:attrName>
+                                        </p:attrNameLst>
+                                      </p:cBhvr>
+                                      <p:to>
+                                        <p:strVal val="visible"/>
+                                      </p:to>
+                                    </p:set>
+                                  </p:childTnLst>
+                                </p:cTn>
+                              </p:par>
+                              <p:par>
+                                <p:cTn id="9" presetID="1" presetClass="entr" presetSubtype="0" fill="hold" grpId="0" nodeType="withEffect">
+                                  <p:stCondLst>
+                                    <p:cond delay="0"/>
+                                  </p:stCondLst>
+                                  <p:childTnLst>
+                                    <p:set>
+                                      <p:cBhvr>
+                                        <p:cTn id="10" dur="1" fill="hold">
+                                          <p:stCondLst>
+                                            <p:cond delay="0"/>
+                                          </p:stCondLst>
+                                        </p:cTn>
+                                        <p:tgtEl>
+                                          <p:spTgt spid="8"/>
+                                        </p:tgtEl>
+                                        <p:attrNameLst>
+                                          <p:attrName>style.visibility</p:attrName>
+                                        </p:attrNameLst>
+                                      </p:cBhvr>
+                                      <p:to>
+                                        <p:strVal val="visible"/>
+                                      </p:to>
+                                    </p:set>
+                                  </p:childTnLst>
+                                </p:cTn>
+                              </p:par>
+                              <p:par>
+                                <p:cTn id="11" presetID="1" presetClass="entr" presetSubtype="0" fill="hold" grpId="0" nodeType="withEffect">
+                                  <p:stCondLst>
+                                    <p:cond delay="0"/>
+                                  </p:stCondLst>
+                                  <p:childTnLst>
+                                    <p:set>
+                                      <p:cBhvr>
+                                        <p:cTn id="12" dur="1" fill="hold">
+                                          <p:stCondLst>
+                                            <p:cond delay="0"/>
+                                          </p:stCondLst>
+                                        </p:cTn>
+                                        <p:tgtEl>
+                                          <p:spTgt spid="6"/>
+                                        </p:tgtEl>
+                                        <p:attrNameLst>
+                                          <p:attrName>style.visibility</p:attrName>
+                                        </p:attrNameLst>
+                                      </p:cBhvr>
+                                      <p:to>
+                                        <p:strVal val="visible"/>
+                                      </p:to>
+                                    </p:set>
+                                  </p:childTnLst>
+                                </p:cTn>
+                              </p:par>
+                            </p:childTnLst>
+                          </p:cTn>
+                        </p:par>
+                      </p:childTnLst>
+                    </p:cTn>
+                  </p:par>
+                  <p:par>
+                    <p:cTn id="13" fill="hold">
+                      <p:stCondLst>
+                        <p:cond delay="indefinite"/>
+                      </p:stCondLst>
+                      <p:childTnLst>
+                        <p:par>
+                          <p:cTn id="14" fill="hold">
+                            <p:stCondLst>
+                              <p:cond delay="0"/>
+                            </p:stCondLst>
+                            <p:childTnLst>
+                              <p:par>
+                                <p:cTn id="15" presetID="1" presetClass="entr" presetSubtype="0" fill="hold" nodeType="clickEffect">
+                                  <p:stCondLst>
+                                    <p:cond delay="0"/>
+                                  </p:stCondLst>
+                                  <p:childTnLst>
+                                    <p:set>
+                                      <p:cBhvr>
+                                        <p:cTn id="16" dur="1" fill="hold">
+                                          <p:stCondLst>
+                                            <p:cond delay="0"/>
+                                          </p:stCondLst>
+                                        </p:cTn>
+                                        <p:tgtEl>
+                                          <p:spTgt spid="2"/>
+                                        </p:tgtEl>
+                                        <p:attrNameLst>
+                                          <p:attrName>style.visibility</p:attrName>
+                                        </p:attrNameLst>
+                                      </p:cBhvr>
+                                      <p:to>
+                                        <p:strVal val="visible"/>
+                                      </p:to>
+                                    </p:set>
+                                  </p:childTnLst>
+                                </p:cTn>
+                              </p:par>
+                              <p:par>
+                                <p:cTn id="17" presetID="1" presetClass="entr" presetSubtype="0" fill="hold" grpId="0" nodeType="withEffect">
+                                  <p:stCondLst>
+                                    <p:cond delay="0"/>
+                                  </p:stCondLst>
+                                  <p:childTnLst>
+                                    <p:set>
+                                      <p:cBhvr>
+                                        <p:cTn id="18" dur="1" fill="hold">
+                                          <p:stCondLst>
+                                            <p:cond delay="0"/>
+                                          </p:stCondLst>
+                                        </p:cTn>
+                                        <p:tgtEl>
+                                          <p:spTgt spid="3"/>
+                                        </p:tgtEl>
+                                        <p:attrNameLst>
+                                          <p:attrName>style.visibility</p:attrName>
+                                        </p:attrNameLst>
+                                      </p:cBhvr>
+                                      <p:to>
+                                        <p:strVal val="visible"/>
+                                      </p:to>
+                                    </p:set>
+                                  </p:childTnLst>
+                                </p:cTn>
+                              </p:par>
+                            </p:childTnLst>
+                          </p:cTn>
+                        </p:par>
+                      </p:childTnLst>
+                    </p:cTn>
+                  </p:par>
+                </p:childTnLst>
+              </p:cTn>
+              <p:prevCondLst>
+                <p:cond evt="onPrev" delay="0">
+                  <p:tgtEl>
+                    <p:sldTgt/>
+                  </p:tgtEl>
+                </p:cond>
+              </p:prevCondLst>
+              <p:nextCondLst>
+                <p:cond evt="onNext" delay="0">
+                  <p:tgtEl>
+                    <p:sldTgt/>
+                  </p:tgtEl>
+                </p:cond>
+              </p:nextCondLst>
+            </p:seq>
+          </p:childTnLst>
+        </p:cTn>
+      </p:par>
+    </p:tnLst>
+    <p:bldLst>
+      <p:bldP spid="3" grpId="0"/>
+      <p:bldP spid="6" grpId="0"/>
+      <p:bldP spid="7" grpId="0"/>
+      <p:bldP spid="8" grpId="0"/>
+    </p:bldLst>
+  </p:timing>
 </p:sld>
 </file>
 

</xml_diff>